<commit_message>
Introduction to MMM deck (29 slides) based on the MMM resource search
Definition, inputs and outputs, MMM vs attribution vs experiments, base plus incremental,
adstock, saturation, empirical generalisations, pitfalls, validation, Bayesian MMM,
open-source tools, the course path and the case study; charts from the Alpenglow data.
Slide 9 flags the naive model's media share as inflated by seasonal budgets.

Co-Authored-By: Claude Opus 5.5 <noreply@anthropic.com>
Claude-Session: https://claude.ai/code/session_01TbrdxHn7W6FVXXnpqzNytd
</commit_message>
<xml_diff>
--- a/slides/02a_intro-to-mmm_WT26-27.pptx
+++ b/slides/02a_intro-to-mmm_WT26-27.pptx
@@ -2791,7 +2791,7 @@
           <a:lstStyle/>
           <a:p>
             <a:r>
-              <a:t>The chart splits German weekly sales in 2025 into a base and the part the model attributes to media. It comes from a deliberately simple regression (all five channels with the same carryover of 0.5, no saturation); in this first model media account for about 41 % of fitted sales. That number is illustrative only: Session 2 builds a proper model and you will see how much it moves. The dashed line is actual sales; the gap to the coloured area is what the model cannot explain.</a:t>
+              <a:t>The chart splits German weekly sales in 2025 into a base and the part the model attributes to media. It comes from a deliberately simple regression (all five channels with the same carryover of 0.5, no saturation); in this first model media account for about 41 % of fitted sales. That number is too high: Alpenglow raises its budgets before Christmas, when people buy chocolate anyway, so a naive model credits media with part of the seasonal demand (the endogeneity pitfall later in this deck). Session 2 builds a proper model and you will see the media share fall considerably. The dashed line is actual sales; the gap to the coloured area is what the model cannot explain.</a:t>
             </a:r>
           </a:p>
         </p:txBody>
@@ -11602,7 +11602,7 @@
                   <a:schemeClr val="tx2"/>
                 </a:solidFill>
               </a:rPr>
-              <a:t>less per euro</a:t>
+              <a:t>less per €</a:t>
             </a:r>
           </a:p>
         </p:txBody>
@@ -23613,7 +23613,7 @@
                   <a:srgbClr val="595959"/>
                 </a:solidFill>
               </a:rPr>
-              <a:t>Sources: Runge et al. 2024; Meridian and PyMC-Marketing documentation; Customer Needs and Solutions review 2026</a:t>
+              <a:t>Sources: Runge et al. 2024; Meridian and PyMC-Marketing documentation; open-source MMM review (2026)</a:t>
             </a:r>
           </a:p>
         </p:txBody>
@@ -25419,7 +25419,7 @@
         <p:spPr>
           <a:xfrm>
             <a:off x="457200" y="2423160"/>
-            <a:ext cx="2651760" cy="1737360"/>
+            <a:ext cx="2651760" cy="1417320"/>
           </a:xfrm>
           <a:prstGeom prst="rect">
             <a:avLst/>
@@ -25566,7 +25566,7 @@
         <p:spPr>
           <a:xfrm>
             <a:off x="621792" y="2560320"/>
-            <a:ext cx="2350008" cy="1463040"/>
+            <a:ext cx="2350008" cy="1143000"/>
           </a:xfrm>
           <a:prstGeom prst="rect">
             <a:avLst/>
@@ -25629,7 +25629,7 @@
         <p:spPr>
           <a:xfrm>
             <a:off x="3246120" y="2423160"/>
-            <a:ext cx="2651760" cy="1737360"/>
+            <a:ext cx="2651760" cy="1417320"/>
           </a:xfrm>
           <a:prstGeom prst="rect">
             <a:avLst/>
@@ -25776,7 +25776,7 @@
         <p:spPr>
           <a:xfrm>
             <a:off x="3410712" y="2560320"/>
-            <a:ext cx="2350008" cy="1463040"/>
+            <a:ext cx="2350008" cy="1143000"/>
           </a:xfrm>
           <a:prstGeom prst="rect">
             <a:avLst/>
@@ -25859,7 +25859,7 @@
         <p:spPr>
           <a:xfrm>
             <a:off x="6035040" y="2423160"/>
-            <a:ext cx="2651760" cy="1737360"/>
+            <a:ext cx="2651760" cy="1417320"/>
           </a:xfrm>
           <a:prstGeom prst="rect">
             <a:avLst/>
@@ -26006,7 +26006,7 @@
         <p:spPr>
           <a:xfrm>
             <a:off x="6199632" y="2560320"/>
-            <a:ext cx="2350008" cy="1463040"/>
+            <a:ext cx="2350008" cy="1143000"/>
           </a:xfrm>
           <a:prstGeom prst="rect">
             <a:avLst/>
@@ -26088,7 +26088,7 @@
         </p:nvSpPr>
         <p:spPr>
           <a:xfrm>
-            <a:off x="457200" y="4343400"/>
+            <a:off x="457200" y="4005072"/>
             <a:ext cx="8229600" cy="685800"/>
           </a:xfrm>
           <a:prstGeom prst="rect">
@@ -26138,7 +26138,7 @@
         </p:blipFill>
         <p:spPr>
           <a:xfrm>
-            <a:off x="658368" y="4503420"/>
+            <a:off x="658368" y="4165092"/>
             <a:ext cx="365760" cy="365760"/>
           </a:xfrm>
           <a:prstGeom prst="rect">
@@ -26154,7 +26154,7 @@
         </p:nvSpPr>
         <p:spPr>
           <a:xfrm>
-            <a:off x="1207008" y="4343400"/>
+            <a:off x="1207008" y="4005072"/>
             <a:ext cx="7315200" cy="685800"/>
           </a:xfrm>
           <a:prstGeom prst="rect">
@@ -26188,6 +26188,53 @@
                 </a:solidFill>
               </a:rPr>
               <a:t>the report renders from a fresh copy of your repository.</a:t>
+            </a:r>
+          </a:p>
+        </p:txBody>
+      </p:sp>
+      <p:sp>
+        <p:nvSpPr>
+          <p:cNvPr id="32" name="Case where"/>
+          <p:cNvSpPr txBox="1"/>
+          <p:nvPr/>
+        </p:nvSpPr>
+        <p:spPr>
+          <a:xfrm>
+            <a:off x="457200" y="4754880"/>
+            <a:ext cx="8229600" cy="292608"/>
+          </a:xfrm>
+          <a:prstGeom prst="rect">
+            <a:avLst/>
+          </a:prstGeom>
+          <a:noFill/>
+        </p:spPr>
+        <p:txBody>
+          <a:bodyPr wrap="square" lIns="0" rIns="0" tIns="0" bIns="0" anchor="ctr">
+            <a:noAutofit/>
+          </a:bodyPr>
+          <a:lstStyle/>
+          <a:p>
+            <a:pPr algn="l">
+              <a:spcAft>
+                <a:spcPts val="400"/>
+              </a:spcAft>
+            </a:pPr>
+            <a:r>
+              <a:rPr sz="1200" b="1" lang="en-GB">
+                <a:solidFill>
+                  <a:schemeClr val="tx2"/>
+                </a:solidFill>
+              </a:rPr>
+              <a:t>Brief, data and assessment criteria: </a:t>
+            </a:r>
+            <a:r>
+              <a:rPr sz="1200" b="0" lang="en-GB">
+                <a:solidFill>
+                  <a:schemeClr val="tx2"/>
+                </a:solidFill>
+                <a:latin typeface="Consolas"/>
+              </a:rPr>
+              <a:t>assignments/group-project/ and Canvas</a:t>
             </a:r>
           </a:p>
         </p:txBody>
@@ -32925,7 +32972,7 @@
                   <a:schemeClr val="bg1"/>
                 </a:solidFill>
               </a:rPr>
-              <a:t>First model: </a:t>
+              <a:t>Naive model: </a:t>
             </a:r>
             <a:r>
               <a:rPr sz="1200" b="0" lang="en-GB">
@@ -32933,7 +32980,7 @@
                   <a:schemeClr val="bg1"/>
                 </a:solidFill>
               </a:rPr>
-              <a:t>media ≈ 41 % of sales</a:t>
+              <a:t>media ≈ 41 %, too high</a:t>
             </a:r>
           </a:p>
         </p:txBody>
@@ -32971,7 +33018,7 @@
                   <a:srgbClr val="595959"/>
                 </a:solidFill>
               </a:rPr>
-              <a:t>Alpenglow Germany, 2025: a simple first regression for illustration, not the final model.</a:t>
+              <a:t>Alpenglow Germany, 2025, naive regression: budgets follow Christmas demand, so media get credit for seasonal sales (see the pitfalls slide).</a:t>
             </a:r>
           </a:p>
         </p:txBody>

</xml_diff>